<commit_message>
Update 01b slides and public README
</commit_message>
<xml_diff>
--- a/lectures/01b-reproducible-discovery/01b-reproducible-discovery-slides.pptx
+++ b/lectures/01b-reproducible-discovery/01b-reproducible-discovery-slides.pptx
@@ -5,16 +5,16 @@
     <p:sldMasterId id="2147483648" r:id="rId1"/>
   </p:sldMasterIdLst>
   <p:notesMasterIdLst>
-    <p:notesMasterId r:id="rId9"/>
+    <p:notesMasterId r:id="rId2"/>
   </p:notesMasterIdLst>
   <p:sldIdLst>
-    <p:sldId id="256" r:id="rId2"/>
-    <p:sldId id="257" r:id="rId3"/>
-    <p:sldId id="258" r:id="rId4"/>
-    <p:sldId id="259" r:id="rId5"/>
-    <p:sldId id="260" r:id="rId6"/>
-    <p:sldId id="261" r:id="rId7"/>
-    <p:sldId id="262" r:id="rId8"/>
+    <p:sldId id="256" r:id="rId7"/>
+    <p:sldId id="257" r:id="rId8"/>
+    <p:sldId id="258" r:id="rId9"/>
+    <p:sldId id="259" r:id="rId10"/>
+    <p:sldId id="260" r:id="rId11"/>
+    <p:sldId id="261" r:id="rId12"/>
+    <p:sldId id="262" r:id="rId13"/>
   </p:sldIdLst>
   <p:sldSz cx="12192000" cy="6858000"/>
   <p:notesSz cx="6858000" cy="9144000"/>
@@ -203,7 +203,7 @@
           <a:p>
             <a:fld id="{39F5E5A0-55AC-E847-ACDE-4E9872246A32}" type="datetimeFigureOut">
               <a:rPr lang="en-US" smtClean="0"/>
-              <a:t>8/20/26</a:t>
+              <a:t>11/13/25</a:t>
             </a:fld>
             <a:endParaRPr lang="en-US"/>
           </a:p>
@@ -471,7 +471,7 @@
 </file>
 
 <file path=ppt/notesSlides/notesSlide1.xml><?xml version="1.0" encoding="utf-8"?>
-<p:notes xmlns:a="http://schemas.openxmlformats.org/drawingml/2006/main" xmlns:r="http://schemas.openxmlformats.org/officeDocument/2006/relationships" xmlns:p="http://schemas.openxmlformats.org/presentationml/2006/main">
+<p:notes xmlns:a="http://schemas.openxmlformats.org/drawingml/2006/main" xmlns:p="http://schemas.openxmlformats.org/presentationml/2006/main" xmlns:r="http://schemas.openxmlformats.org/officeDocument/2006/relationships">
   <p:cSld>
     <p:spTree>
       <p:nvGrpSpPr>
@@ -491,7 +491,7 @@
         <p:nvSpPr>
           <p:cNvPr id="2" name="Slide Image Placeholder 1"/>
           <p:cNvSpPr>
-            <a:spLocks noGrp="1" noRot="1" noChangeAspect="1"/>
+            <a:spLocks noGrp="1"/>
           </p:cNvSpPr>
           <p:nvPr>
             <p:ph type="sldImg" idx="2"/>
@@ -506,7 +506,7 @@
             <a:spLocks noGrp="1"/>
           </p:cNvSpPr>
           <p:nvPr>
-            <p:ph type="body" sz="quarter" idx="3"/>
+            <p:ph type="body" idx="3" sz="quarter"/>
           </p:nvPr>
         </p:nvSpPr>
         <p:spPr/>
@@ -520,6 +520,11 @@
           </a:p>
           <a:p>
             <a:r>
+              <a:t>- https://www.oreilly.com/library/view/practical-statistics-for/9781492072935/</a:t>
+            </a:r>
+          </a:p>
+          <a:p>
+            <a:r>
               <a:t>- https://jakevdp.github.io/PythonDataScienceHandbook/</a:t>
             </a:r>
           </a:p>
@@ -532,7 +537,7 @@
             <a:spLocks noGrp="1"/>
           </p:cNvSpPr>
           <p:nvPr>
-            <p:ph type="sldNum" sz="quarter" idx="5"/>
+            <p:ph type="sldNum" idx="5" sz="quarter"/>
           </p:nvPr>
         </p:nvSpPr>
         <p:spPr/>
@@ -546,7 +551,7 @@
 </file>
 
 <file path=ppt/notesSlides/notesSlide2.xml><?xml version="1.0" encoding="utf-8"?>
-<p:notes xmlns:a="http://schemas.openxmlformats.org/drawingml/2006/main" xmlns:r="http://schemas.openxmlformats.org/officeDocument/2006/relationships" xmlns:p="http://schemas.openxmlformats.org/presentationml/2006/main">
+<p:notes xmlns:a="http://schemas.openxmlformats.org/drawingml/2006/main" xmlns:p="http://schemas.openxmlformats.org/presentationml/2006/main" xmlns:r="http://schemas.openxmlformats.org/officeDocument/2006/relationships">
   <p:cSld>
     <p:spTree>
       <p:nvGrpSpPr>
@@ -566,7 +571,7 @@
         <p:nvSpPr>
           <p:cNvPr id="2" name="Slide Image Placeholder 1"/>
           <p:cNvSpPr>
-            <a:spLocks noGrp="1" noRot="1" noChangeAspect="1"/>
+            <a:spLocks noGrp="1"/>
           </p:cNvSpPr>
           <p:nvPr>
             <p:ph type="sldImg" idx="2"/>
@@ -581,7 +586,7 @@
             <a:spLocks noGrp="1"/>
           </p:cNvSpPr>
           <p:nvPr>
-            <p:ph type="body" sz="quarter" idx="3"/>
+            <p:ph type="body" idx="3" sz="quarter"/>
           </p:nvPr>
         </p:nvSpPr>
         <p:spPr/>
@@ -637,7 +642,7 @@
             <a:spLocks noGrp="1"/>
           </p:cNvSpPr>
           <p:nvPr>
-            <p:ph type="sldNum" sz="quarter" idx="5"/>
+            <p:ph type="sldNum" idx="5" sz="quarter"/>
           </p:nvPr>
         </p:nvSpPr>
         <p:spPr/>
@@ -795,10 +800,11 @@
           <a:bodyPr/>
           <a:lstStyle/>
           <a:p>
-            <a:r>
-              <a:rPr lang="en-US"/>
-              <a:t>INSY 7130</a:t>
-            </a:r>
+            <a:fld id="{A07A4B5E-1C26-124E-B6D0-6EA9A0EA2A27}" type="datetime1">
+              <a:rPr lang="en-US" smtClean="0"/>
+              <a:t>11/13/25</a:t>
+            </a:fld>
+            <a:endParaRPr lang="en-US"/>
           </a:p>
         </p:txBody>
       </p:sp>
@@ -825,7 +831,7 @@
           <a:p>
             <a:r>
               <a:rPr lang="en-US"/>
-              <a:t>Industrial &amp; Systems Engineering, Auburn University</a:t>
+              <a:t>Dan O'Leary - Industrial &amp; Systems Engineering, Auburn University - INSY 6500</a:t>
             </a:r>
           </a:p>
         </p:txBody>
@@ -995,10 +1001,11 @@
           <a:bodyPr/>
           <a:lstStyle/>
           <a:p>
-            <a:r>
-              <a:rPr lang="en-US"/>
-              <a:t>INSY 7130</a:t>
-            </a:r>
+            <a:fld id="{0877FC37-E003-A243-B2B7-19BF43DDBDE2}" type="datetime1">
+              <a:rPr lang="en-US" smtClean="0"/>
+              <a:t>11/13/25</a:t>
+            </a:fld>
+            <a:endParaRPr lang="en-US"/>
           </a:p>
         </p:txBody>
       </p:sp>
@@ -1025,7 +1032,7 @@
           <a:p>
             <a:r>
               <a:rPr lang="en-US"/>
-              <a:t>Industrial &amp; Systems Engineering, Auburn University</a:t>
+              <a:t>Dan O'Leary - Industrial &amp; Systems Engineering, Auburn University - INSY 6500</a:t>
             </a:r>
           </a:p>
         </p:txBody>
@@ -1205,10 +1212,11 @@
           <a:bodyPr/>
           <a:lstStyle/>
           <a:p>
-            <a:r>
-              <a:rPr lang="en-US"/>
-              <a:t>INSY 7130</a:t>
-            </a:r>
+            <a:fld id="{38646512-B9DA-2D41-B0E8-CD84CAD58A04}" type="datetime1">
+              <a:rPr lang="en-US" smtClean="0"/>
+              <a:t>11/13/25</a:t>
+            </a:fld>
+            <a:endParaRPr lang="en-US"/>
           </a:p>
         </p:txBody>
       </p:sp>
@@ -1235,7 +1243,7 @@
           <a:p>
             <a:r>
               <a:rPr lang="en-US"/>
-              <a:t>Industrial &amp; Systems Engineering, Auburn University</a:t>
+              <a:t>Dan O'Leary - Industrial &amp; Systems Engineering, Auburn University - INSY 6500</a:t>
             </a:r>
           </a:p>
         </p:txBody>
@@ -1405,10 +1413,11 @@
           <a:bodyPr/>
           <a:lstStyle/>
           <a:p>
-            <a:r>
-              <a:rPr lang="en-US"/>
-              <a:t>INSY 7130</a:t>
-            </a:r>
+            <a:fld id="{A5F914C2-28D1-374B-A00B-F2948A4A63A2}" type="datetime1">
+              <a:rPr lang="en-US" smtClean="0"/>
+              <a:t>11/13/25</a:t>
+            </a:fld>
+            <a:endParaRPr lang="en-US"/>
           </a:p>
         </p:txBody>
       </p:sp>
@@ -1435,7 +1444,7 @@
           <a:p>
             <a:r>
               <a:rPr lang="en-US"/>
-              <a:t>Industrial &amp; Systems Engineering, Auburn University</a:t>
+              <a:t>Dan O'Leary - Industrial &amp; Systems Engineering, Auburn University - INSY 6500</a:t>
             </a:r>
           </a:p>
         </p:txBody>
@@ -1682,10 +1691,11 @@
           <a:bodyPr/>
           <a:lstStyle/>
           <a:p>
-            <a:r>
-              <a:rPr lang="en-US"/>
-              <a:t>INSY 7130</a:t>
-            </a:r>
+            <a:fld id="{A99A1379-6E3B-0C41-AA96-DB39A925970C}" type="datetime1">
+              <a:rPr lang="en-US" smtClean="0"/>
+              <a:t>11/13/25</a:t>
+            </a:fld>
+            <a:endParaRPr lang="en-US"/>
           </a:p>
         </p:txBody>
       </p:sp>
@@ -1712,7 +1722,7 @@
           <a:p>
             <a:r>
               <a:rPr lang="en-US"/>
-              <a:t>Industrial &amp; Systems Engineering, Auburn University</a:t>
+              <a:t>Dan O'Leary - Industrial &amp; Systems Engineering, Auburn University - INSY 6500</a:t>
             </a:r>
           </a:p>
         </p:txBody>
@@ -1949,10 +1959,11 @@
           <a:bodyPr/>
           <a:lstStyle/>
           <a:p>
-            <a:r>
-              <a:rPr lang="en-US"/>
-              <a:t>INSY 7130</a:t>
-            </a:r>
+            <a:fld id="{63C68D1A-A11B-7849-ABF8-C0267CE746DC}" type="datetime1">
+              <a:rPr lang="en-US" smtClean="0"/>
+              <a:t>11/13/25</a:t>
+            </a:fld>
+            <a:endParaRPr lang="en-US"/>
           </a:p>
         </p:txBody>
       </p:sp>
@@ -1979,7 +1990,7 @@
           <a:p>
             <a:r>
               <a:rPr lang="en-US"/>
-              <a:t>Industrial &amp; Systems Engineering, Auburn University</a:t>
+              <a:t>Dan O'Leary - Industrial &amp; Systems Engineering, Auburn University - INSY 6500</a:t>
             </a:r>
           </a:p>
         </p:txBody>
@@ -2363,10 +2374,11 @@
           <a:bodyPr/>
           <a:lstStyle/>
           <a:p>
-            <a:r>
-              <a:rPr lang="en-US"/>
-              <a:t>INSY 7130</a:t>
-            </a:r>
+            <a:fld id="{7ABCB532-C614-4A4E-AB18-C10AE7923787}" type="datetime1">
+              <a:rPr lang="en-US" smtClean="0"/>
+              <a:t>11/13/25</a:t>
+            </a:fld>
+            <a:endParaRPr lang="en-US"/>
           </a:p>
         </p:txBody>
       </p:sp>
@@ -2393,7 +2405,7 @@
           <a:p>
             <a:r>
               <a:rPr lang="en-US"/>
-              <a:t>Industrial &amp; Systems Engineering, Auburn University</a:t>
+              <a:t>Dan O'Leary - Industrial &amp; Systems Engineering, Auburn University - INSY 6500</a:t>
             </a:r>
           </a:p>
         </p:txBody>
@@ -2506,10 +2518,11 @@
           <a:bodyPr/>
           <a:lstStyle/>
           <a:p>
-            <a:r>
-              <a:rPr lang="en-US"/>
-              <a:t>INSY 7130</a:t>
-            </a:r>
+            <a:fld id="{8766D4E8-0E2F-7C44-B8F4-1671C91FF951}" type="datetime1">
+              <a:rPr lang="en-US" smtClean="0"/>
+              <a:t>11/13/25</a:t>
+            </a:fld>
+            <a:endParaRPr lang="en-US"/>
           </a:p>
         </p:txBody>
       </p:sp>
@@ -2536,7 +2549,7 @@
           <a:p>
             <a:r>
               <a:rPr lang="en-US"/>
-              <a:t>Industrial &amp; Systems Engineering, Auburn University</a:t>
+              <a:t>Dan O'Leary - Industrial &amp; Systems Engineering, Auburn University - INSY 6500</a:t>
             </a:r>
           </a:p>
         </p:txBody>
@@ -2621,10 +2634,11 @@
           <a:bodyPr/>
           <a:lstStyle/>
           <a:p>
-            <a:r>
-              <a:rPr lang="en-US"/>
-              <a:t>INSY 7130</a:t>
-            </a:r>
+            <a:fld id="{BAB5F20C-12C2-3C45-A373-97ED17C3673A}" type="datetime1">
+              <a:rPr lang="en-US" smtClean="0"/>
+              <a:t>11/13/25</a:t>
+            </a:fld>
+            <a:endParaRPr lang="en-US"/>
           </a:p>
         </p:txBody>
       </p:sp>
@@ -2651,7 +2665,7 @@
           <a:p>
             <a:r>
               <a:rPr lang="en-US"/>
-              <a:t>Industrial &amp; Systems Engineering, Auburn University</a:t>
+              <a:t>Dan O'Leary - Industrial &amp; Systems Engineering, Auburn University - INSY 6500</a:t>
             </a:r>
           </a:p>
         </p:txBody>
@@ -2934,10 +2948,11 @@
           <a:bodyPr/>
           <a:lstStyle/>
           <a:p>
-            <a:r>
-              <a:rPr lang="en-US"/>
-              <a:t>INSY 7130</a:t>
-            </a:r>
+            <a:fld id="{EED680B0-A087-224F-A411-2E2C3DF11103}" type="datetime1">
+              <a:rPr lang="en-US" smtClean="0"/>
+              <a:t>11/13/25</a:t>
+            </a:fld>
+            <a:endParaRPr lang="en-US"/>
           </a:p>
         </p:txBody>
       </p:sp>
@@ -2964,7 +2979,7 @@
           <a:p>
             <a:r>
               <a:rPr lang="en-US"/>
-              <a:t>Industrial &amp; Systems Engineering, Auburn University</a:t>
+              <a:t>Dan O'Leary - Industrial &amp; Systems Engineering, Auburn University - INSY 6500</a:t>
             </a:r>
           </a:p>
         </p:txBody>
@@ -3224,10 +3239,11 @@
           <a:bodyPr/>
           <a:lstStyle/>
           <a:p>
-            <a:r>
-              <a:rPr lang="en-US"/>
-              <a:t>INSY 7130</a:t>
-            </a:r>
+            <a:fld id="{8C6324FE-5E0C-E042-B8D7-68C9B78C8A7E}" type="datetime1">
+              <a:rPr lang="en-US" smtClean="0"/>
+              <a:t>11/13/25</a:t>
+            </a:fld>
+            <a:endParaRPr lang="en-US"/>
           </a:p>
         </p:txBody>
       </p:sp>
@@ -3254,7 +3270,7 @@
           <a:p>
             <a:r>
               <a:rPr lang="en-US"/>
-              <a:t>Industrial &amp; Systems Engineering, Auburn University</a:t>
+              <a:t>Dan O'Leary - Industrial &amp; Systems Engineering, Auburn University - INSY 6500</a:t>
             </a:r>
           </a:p>
         </p:txBody>
@@ -3467,10 +3483,11 @@
             </a:lvl1pPr>
           </a:lstStyle>
           <a:p>
-            <a:r>
-              <a:rPr lang="en-US"/>
-              <a:t>INSY 7130</a:t>
-            </a:r>
+            <a:fld id="{2516B177-E0F5-3C40-8917-372D014E4B76}" type="datetime1">
+              <a:rPr lang="en-US" smtClean="0"/>
+              <a:t>11/13/25</a:t>
+            </a:fld>
+            <a:endParaRPr lang="en-US"/>
           </a:p>
         </p:txBody>
       </p:sp>
@@ -3514,10 +3531,9 @@
           </a:lstStyle>
           <a:p>
             <a:r>
-              <a:rPr lang="en-US"/>
-              <a:t>Industrial &amp; Systems Engineering, Auburn University</a:t>
-            </a:r>
-            <a:endParaRPr lang="en-US" dirty="0"/>
+              <a:rPr lang="en-US" dirty="0"/>
+              <a:t>Dan O'Leary - Industrial &amp; Systems Engineering, Auburn University - INSY 6500</a:t>
+            </a:r>
           </a:p>
         </p:txBody>
       </p:sp>
@@ -3589,7 +3605,7 @@
     <p:sldLayoutId id="2147483658" r:id="rId10"/>
     <p:sldLayoutId id="2147483659" r:id="rId11"/>
   </p:sldLayoutIdLst>
-  <p:hf hdr="0"/>
+  <p:hf hdr="0" dt="0"/>
   <p:txStyles>
     <p:titleStyle>
       <a:lvl1pPr algn="l" defTabSz="914400" rtl="0" eaLnBrk="1" latinLnBrk="0" hangingPunct="1">
@@ -3874,7 +3890,7 @@
 </file>
 
 <file path=ppt/slides/slide1.xml><?xml version="1.0" encoding="utf-8"?>
-<p:sld xmlns:a="http://schemas.openxmlformats.org/drawingml/2006/main" xmlns:r="http://schemas.openxmlformats.org/officeDocument/2006/relationships" xmlns:p="http://schemas.openxmlformats.org/presentationml/2006/main">
+<p:sld xmlns:a="http://schemas.openxmlformats.org/drawingml/2006/main" xmlns:p="http://schemas.openxmlformats.org/presentationml/2006/main" xmlns:r="http://schemas.openxmlformats.org/officeDocument/2006/relationships">
   <p:cSld>
     <p:spTree>
       <p:nvGrpSpPr>
@@ -3882,14 +3898,7 @@
         <p:cNvGrpSpPr/>
         <p:nvPr/>
       </p:nvGrpSpPr>
-      <p:grpSpPr>
-        <a:xfrm>
-          <a:off x="0" y="0"/>
-          <a:ext cx="0" cy="0"/>
-          <a:chOff x="0" y="0"/>
-          <a:chExt cx="0" cy="0"/>
-        </a:xfrm>
-      </p:grpSpPr>
+      <p:grpSpPr/>
       <p:sp>
         <p:nvSpPr>
           <p:cNvPr id="2" name="Title 1"/>
@@ -3929,91 +3938,6 @@
             <a:r>
               <a:t>01b Reproducible Discovery</a:t>
             </a:r>
-          </a:p>
-        </p:txBody>
-      </p:sp>
-      <p:sp>
-        <p:nvSpPr>
-          <p:cNvPr id="4" name="Date Placeholder 3">
-            <a:extLst>
-              <a:ext uri="{FF2B5EF4-FFF2-40B4-BE49-F238E27FC236}">
-                <a16:creationId xmlns:a16="http://schemas.microsoft.com/office/drawing/2014/main" id="{17C87700-9AF6-6CBB-F90D-6C9E2FED02B3}"/>
-              </a:ext>
-            </a:extLst>
-          </p:cNvPr>
-          <p:cNvSpPr>
-            <a:spLocks noGrp="1"/>
-          </p:cNvSpPr>
-          <p:nvPr>
-            <p:ph type="dt" sz="half" idx="10"/>
-          </p:nvPr>
-        </p:nvSpPr>
-        <p:spPr/>
-        <p:txBody>
-          <a:bodyPr/>
-          <a:lstStyle/>
-          <a:p>
-            <a:r>
-              <a:rPr lang="en-US"/>
-              <a:t>INSY 7130</a:t>
-            </a:r>
-          </a:p>
-        </p:txBody>
-      </p:sp>
-      <p:sp>
-        <p:nvSpPr>
-          <p:cNvPr id="5" name="Footer Placeholder 4">
-            <a:extLst>
-              <a:ext uri="{FF2B5EF4-FFF2-40B4-BE49-F238E27FC236}">
-                <a16:creationId xmlns:a16="http://schemas.microsoft.com/office/drawing/2014/main" id="{10CE3EE9-696D-CBF6-2868-09DA780A241C}"/>
-              </a:ext>
-            </a:extLst>
-          </p:cNvPr>
-          <p:cNvSpPr>
-            <a:spLocks noGrp="1"/>
-          </p:cNvSpPr>
-          <p:nvPr>
-            <p:ph type="ftr" sz="quarter" idx="11"/>
-          </p:nvPr>
-        </p:nvSpPr>
-        <p:spPr/>
-        <p:txBody>
-          <a:bodyPr/>
-          <a:lstStyle/>
-          <a:p>
-            <a:r>
-              <a:rPr lang="en-US"/>
-              <a:t>Industrial &amp; Systems Engineering, Auburn University</a:t>
-            </a:r>
-          </a:p>
-        </p:txBody>
-      </p:sp>
-      <p:sp>
-        <p:nvSpPr>
-          <p:cNvPr id="6" name="Slide Number Placeholder 5">
-            <a:extLst>
-              <a:ext uri="{FF2B5EF4-FFF2-40B4-BE49-F238E27FC236}">
-                <a16:creationId xmlns:a16="http://schemas.microsoft.com/office/drawing/2014/main" id="{E14EF0F9-3C96-C535-E401-D5E13E586566}"/>
-              </a:ext>
-            </a:extLst>
-          </p:cNvPr>
-          <p:cNvSpPr>
-            <a:spLocks noGrp="1"/>
-          </p:cNvSpPr>
-          <p:nvPr>
-            <p:ph type="sldNum" sz="quarter" idx="12"/>
-          </p:nvPr>
-        </p:nvSpPr>
-        <p:spPr/>
-        <p:txBody>
-          <a:bodyPr/>
-          <a:lstStyle/>
-          <a:p>
-            <a:fld id="{865A0CD8-E904-E941-9989-44DD9BC4F0EA}" type="slidenum">
-              <a:rPr lang="en-US" smtClean="0"/>
-              <a:t>1</a:t>
-            </a:fld>
-            <a:endParaRPr lang="en-US"/>
           </a:p>
         </p:txBody>
       </p:sp>
@@ -4026,7 +3950,7 @@
 </file>
 
 <file path=ppt/slides/slide2.xml><?xml version="1.0" encoding="utf-8"?>
-<p:sld xmlns:a="http://schemas.openxmlformats.org/drawingml/2006/main" xmlns:r="http://schemas.openxmlformats.org/officeDocument/2006/relationships" xmlns:p="http://schemas.openxmlformats.org/presentationml/2006/main">
+<p:sld xmlns:a="http://schemas.openxmlformats.org/drawingml/2006/main" xmlns:p="http://schemas.openxmlformats.org/presentationml/2006/main" xmlns:r="http://schemas.openxmlformats.org/officeDocument/2006/relationships">
   <p:cSld>
     <p:spTree>
       <p:nvGrpSpPr>
@@ -4034,14 +3958,7 @@
         <p:cNvGrpSpPr/>
         <p:nvPr/>
       </p:nvGrpSpPr>
-      <p:grpSpPr>
-        <a:xfrm>
-          <a:off x="0" y="0"/>
-          <a:ext cx="0" cy="0"/>
-          <a:chOff x="0" y="0"/>
-          <a:chExt cx="0" cy="0"/>
-        </a:xfrm>
-      </p:grpSpPr>
+      <p:grpSpPr/>
       <p:sp>
         <p:nvSpPr>
           <p:cNvPr id="2" name="Title 1"/>
@@ -4078,113 +3995,32 @@
           <a:bodyPr/>
           <a:lstStyle/>
           <a:p>
+            <a:pPr/>
             <a:r>
               <a:rPr sz="2800"/>
               <a:t>01b: Make and record a descriptive comparison; refresh a familiar mean test; preview resampling.</a:t>
             </a:r>
           </a:p>
           <a:p>
+            <a:pPr/>
             <a:r>
               <a:rPr sz="2800"/>
               <a:t>02a: Ask whether a pattern would be unusual under a stated no-relationship model.</a:t>
             </a:r>
           </a:p>
           <a:p>
+            <a:pPr/>
             <a:r>
               <a:rPr sz="2800"/>
               <a:t>02b: Use bootstrap resampling to describe uncertainty in an estimate.</a:t>
             </a:r>
           </a:p>
           <a:p>
+            <a:pPr/>
             <a:r>
               <a:rPr sz="2800"/>
               <a:t>Across the unit, keep reproducibility, robustness, validity, and causal claims distinct.</a:t>
             </a:r>
-          </a:p>
-        </p:txBody>
-      </p:sp>
-      <p:sp>
-        <p:nvSpPr>
-          <p:cNvPr id="4" name="Date Placeholder 3">
-            <a:extLst>
-              <a:ext uri="{FF2B5EF4-FFF2-40B4-BE49-F238E27FC236}">
-                <a16:creationId xmlns:a16="http://schemas.microsoft.com/office/drawing/2014/main" id="{AFB7AB1C-93CF-2BD1-C9A2-848228518F60}"/>
-              </a:ext>
-            </a:extLst>
-          </p:cNvPr>
-          <p:cNvSpPr>
-            <a:spLocks noGrp="1"/>
-          </p:cNvSpPr>
-          <p:nvPr>
-            <p:ph type="dt" sz="half" idx="10"/>
-          </p:nvPr>
-        </p:nvSpPr>
-        <p:spPr/>
-        <p:txBody>
-          <a:bodyPr/>
-          <a:lstStyle/>
-          <a:p>
-            <a:r>
-              <a:rPr lang="en-US"/>
-              <a:t>INSY 7130</a:t>
-            </a:r>
-          </a:p>
-        </p:txBody>
-      </p:sp>
-      <p:sp>
-        <p:nvSpPr>
-          <p:cNvPr id="5" name="Footer Placeholder 4">
-            <a:extLst>
-              <a:ext uri="{FF2B5EF4-FFF2-40B4-BE49-F238E27FC236}">
-                <a16:creationId xmlns:a16="http://schemas.microsoft.com/office/drawing/2014/main" id="{9A167702-4E0E-2BBC-C7CA-F09D1C2D2BD8}"/>
-              </a:ext>
-            </a:extLst>
-          </p:cNvPr>
-          <p:cNvSpPr>
-            <a:spLocks noGrp="1"/>
-          </p:cNvSpPr>
-          <p:nvPr>
-            <p:ph type="ftr" sz="quarter" idx="11"/>
-          </p:nvPr>
-        </p:nvSpPr>
-        <p:spPr/>
-        <p:txBody>
-          <a:bodyPr/>
-          <a:lstStyle/>
-          <a:p>
-            <a:r>
-              <a:rPr lang="en-US"/>
-              <a:t>Industrial &amp; Systems Engineering, Auburn University</a:t>
-            </a:r>
-          </a:p>
-        </p:txBody>
-      </p:sp>
-      <p:sp>
-        <p:nvSpPr>
-          <p:cNvPr id="6" name="Slide Number Placeholder 5">
-            <a:extLst>
-              <a:ext uri="{FF2B5EF4-FFF2-40B4-BE49-F238E27FC236}">
-                <a16:creationId xmlns:a16="http://schemas.microsoft.com/office/drawing/2014/main" id="{5397BD1B-A305-1CF5-6EF8-4FFE7D0DDD14}"/>
-              </a:ext>
-            </a:extLst>
-          </p:cNvPr>
-          <p:cNvSpPr>
-            <a:spLocks noGrp="1"/>
-          </p:cNvSpPr>
-          <p:nvPr>
-            <p:ph type="sldNum" sz="quarter" idx="12"/>
-          </p:nvPr>
-        </p:nvSpPr>
-        <p:spPr/>
-        <p:txBody>
-          <a:bodyPr/>
-          <a:lstStyle/>
-          <a:p>
-            <a:fld id="{865A0CD8-E904-E941-9989-44DD9BC4F0EA}" type="slidenum">
-              <a:rPr lang="en-US" smtClean="0"/>
-              <a:t>2</a:t>
-            </a:fld>
-            <a:endParaRPr lang="en-US"/>
           </a:p>
         </p:txBody>
       </p:sp>
@@ -4197,7 +4033,7 @@
 </file>
 
 <file path=ppt/slides/slide3.xml><?xml version="1.0" encoding="utf-8"?>
-<p:sld xmlns:a="http://schemas.openxmlformats.org/drawingml/2006/main" xmlns:r="http://schemas.openxmlformats.org/officeDocument/2006/relationships" xmlns:p="http://schemas.openxmlformats.org/presentationml/2006/main">
+<p:sld xmlns:a="http://schemas.openxmlformats.org/drawingml/2006/main" xmlns:p="http://schemas.openxmlformats.org/presentationml/2006/main" xmlns:r="http://schemas.openxmlformats.org/officeDocument/2006/relationships">
   <p:cSld>
     <p:spTree>
       <p:nvGrpSpPr>
@@ -4205,14 +4041,7 @@
         <p:cNvGrpSpPr/>
         <p:nvPr/>
       </p:nvGrpSpPr>
-      <p:grpSpPr>
-        <a:xfrm>
-          <a:off x="0" y="0"/>
-          <a:ext cx="0" cy="0"/>
-          <a:chOff x="0" y="0"/>
-          <a:chExt cx="0" cy="0"/>
-        </a:xfrm>
-      </p:grpSpPr>
+      <p:grpSpPr/>
       <p:sp>
         <p:nvSpPr>
           <p:cNvPr id="2" name="Title 1"/>
@@ -4256,24 +4085,28 @@
           </a:bodyPr>
           <a:lstStyle/>
           <a:p>
+            <a:pPr/>
             <a:r>
               <a:rPr sz="2800"/>
               <a:t>A pattern or forecast is a starting point, not a conclusion.</a:t>
             </a:r>
           </a:p>
           <a:p>
+            <a:pPr/>
             <a:r>
               <a:rPr sz="2800"/>
               <a:t>Need a comparison or reference condition before we decide what the result means.</a:t>
             </a:r>
           </a:p>
           <a:p>
+            <a:pPr/>
             <a:r>
               <a:rPr sz="2800"/>
               <a:t>Need evidence that the result is stable enough for its intended use.</a:t>
             </a:r>
           </a:p>
           <a:p>
+            <a:pPr/>
             <a:r>
               <a:rPr sz="2800"/>
               <a:t>State a bounded claim, then identify the next check or decision.</a:t>
@@ -4305,7 +4138,7 @@
           </a:ln>
         </p:spPr>
         <p:txBody>
-          <a:bodyPr wrap="none" lIns="219456" tIns="109728" rIns="219456" bIns="109728" anchor="t">
+          <a:bodyPr wrap="none" anchor="t" lIns="219456" rIns="219456" tIns="109728" bIns="109728">
             <a:noAutofit/>
           </a:bodyPr>
           <a:lstStyle/>
@@ -4334,91 +4167,6 @@
           </a:p>
         </p:txBody>
       </p:sp>
-      <p:sp>
-        <p:nvSpPr>
-          <p:cNvPr id="5" name="Date Placeholder 4">
-            <a:extLst>
-              <a:ext uri="{FF2B5EF4-FFF2-40B4-BE49-F238E27FC236}">
-                <a16:creationId xmlns:a16="http://schemas.microsoft.com/office/drawing/2014/main" id="{FD6232C6-956C-11FC-5362-E1B64517628D}"/>
-              </a:ext>
-            </a:extLst>
-          </p:cNvPr>
-          <p:cNvSpPr>
-            <a:spLocks noGrp="1"/>
-          </p:cNvSpPr>
-          <p:nvPr>
-            <p:ph type="dt" sz="half" idx="10"/>
-          </p:nvPr>
-        </p:nvSpPr>
-        <p:spPr/>
-        <p:txBody>
-          <a:bodyPr/>
-          <a:lstStyle/>
-          <a:p>
-            <a:r>
-              <a:rPr lang="en-US"/>
-              <a:t>INSY 7130</a:t>
-            </a:r>
-          </a:p>
-        </p:txBody>
-      </p:sp>
-      <p:sp>
-        <p:nvSpPr>
-          <p:cNvPr id="6" name="Footer Placeholder 5">
-            <a:extLst>
-              <a:ext uri="{FF2B5EF4-FFF2-40B4-BE49-F238E27FC236}">
-                <a16:creationId xmlns:a16="http://schemas.microsoft.com/office/drawing/2014/main" id="{6D0EF4C8-BBF6-4680-C07C-F44C2CF614DA}"/>
-              </a:ext>
-            </a:extLst>
-          </p:cNvPr>
-          <p:cNvSpPr>
-            <a:spLocks noGrp="1"/>
-          </p:cNvSpPr>
-          <p:nvPr>
-            <p:ph type="ftr" sz="quarter" idx="11"/>
-          </p:nvPr>
-        </p:nvSpPr>
-        <p:spPr/>
-        <p:txBody>
-          <a:bodyPr/>
-          <a:lstStyle/>
-          <a:p>
-            <a:r>
-              <a:rPr lang="en-US"/>
-              <a:t>Industrial &amp; Systems Engineering, Auburn University</a:t>
-            </a:r>
-          </a:p>
-        </p:txBody>
-      </p:sp>
-      <p:sp>
-        <p:nvSpPr>
-          <p:cNvPr id="7" name="Slide Number Placeholder 6">
-            <a:extLst>
-              <a:ext uri="{FF2B5EF4-FFF2-40B4-BE49-F238E27FC236}">
-                <a16:creationId xmlns:a16="http://schemas.microsoft.com/office/drawing/2014/main" id="{F58F804B-2D42-4247-17DD-70FCA6820485}"/>
-              </a:ext>
-            </a:extLst>
-          </p:cNvPr>
-          <p:cNvSpPr>
-            <a:spLocks noGrp="1"/>
-          </p:cNvSpPr>
-          <p:nvPr>
-            <p:ph type="sldNum" sz="quarter" idx="12"/>
-          </p:nvPr>
-        </p:nvSpPr>
-        <p:spPr/>
-        <p:txBody>
-          <a:bodyPr/>
-          <a:lstStyle/>
-          <a:p>
-            <a:fld id="{865A0CD8-E904-E941-9989-44DD9BC4F0EA}" type="slidenum">
-              <a:rPr lang="en-US" smtClean="0"/>
-              <a:t>3</a:t>
-            </a:fld>
-            <a:endParaRPr lang="en-US"/>
-          </a:p>
-        </p:txBody>
-      </p:sp>
     </p:spTree>
   </p:cSld>
   <p:clrMapOvr>
@@ -4428,7 +4176,7 @@
 </file>
 
 <file path=ppt/slides/slide4.xml><?xml version="1.0" encoding="utf-8"?>
-<p:sld xmlns:a="http://schemas.openxmlformats.org/drawingml/2006/main" xmlns:r="http://schemas.openxmlformats.org/officeDocument/2006/relationships" xmlns:p="http://schemas.openxmlformats.org/presentationml/2006/main">
+<p:sld xmlns:a="http://schemas.openxmlformats.org/drawingml/2006/main" xmlns:p="http://schemas.openxmlformats.org/presentationml/2006/main" xmlns:r="http://schemas.openxmlformats.org/officeDocument/2006/relationships">
   <p:cSld>
     <p:spTree>
       <p:nvGrpSpPr>
@@ -4436,14 +4184,7 @@
         <p:cNvGrpSpPr/>
         <p:nvPr/>
       </p:nvGrpSpPr>
-      <p:grpSpPr>
-        <a:xfrm>
-          <a:off x="0" y="0"/>
-          <a:ext cx="0" cy="0"/>
-          <a:chOff x="0" y="0"/>
-          <a:chExt cx="0" cy="0"/>
-        </a:xfrm>
-      </p:grpSpPr>
+      <p:grpSpPr/>
       <p:sp>
         <p:nvSpPr>
           <p:cNvPr id="2" name="Title 1"/>
@@ -4480,6 +4221,18 @@
           <a:bodyPr/>
           <a:lstStyle/>
           <a:p>
+            <a:pPr/>
+            <a:r>
+              <a:rPr sz="2800" i="1"/>
+              <a:t>Practical Statistics for Data Scientists</a:t>
+            </a:r>
+            <a:r>
+              <a:rPr sz="2800"/>
+              <a:t> by Peter Bruce, Andrew Bruce, and Peter Gedeck is the closest reference for Unit 1's statistical reasoning, inference, and resampling.</a:t>
+            </a:r>
+          </a:p>
+          <a:p>
+            <a:pPr/>
             <a:r>
               <a:rPr sz="2800"/>
               <a:t>Jake VanderPlas's </a:t>
@@ -4490,105 +4243,15 @@
             </a:r>
             <a:r>
               <a:rPr sz="2800"/>
-              <a:t> is the most useful general reference for this course's Python toolkit.</a:t>
-            </a:r>
-          </a:p>
-          <a:p>
+              <a:t> is the companion reference for arrays, DataFrames, plotting, and the scientific-Python ecosystem.</a:t>
+            </a:r>
+          </a:p>
+          <a:p>
+            <a:pPr/>
             <a:r>
               <a:rPr sz="2800"/>
-              <a:t>Use it to refresh arrays, DataFrames, plotting, and the broad scientific-Python ecosystem.</a:t>
-            </a:r>
-          </a:p>
-          <a:p>
-            <a:r>
-              <a:rPr sz="2800"/>
-              <a:t>Read it selectively: it is a reference to return to, not a second course to complete.</a:t>
-            </a:r>
-          </a:p>
-        </p:txBody>
-      </p:sp>
-      <p:sp>
-        <p:nvSpPr>
-          <p:cNvPr id="4" name="Date Placeholder 3">
-            <a:extLst>
-              <a:ext uri="{FF2B5EF4-FFF2-40B4-BE49-F238E27FC236}">
-                <a16:creationId xmlns:a16="http://schemas.microsoft.com/office/drawing/2014/main" id="{33DFE04E-5F9E-179B-D443-00CE674587F5}"/>
-              </a:ext>
-            </a:extLst>
-          </p:cNvPr>
-          <p:cNvSpPr>
-            <a:spLocks noGrp="1"/>
-          </p:cNvSpPr>
-          <p:nvPr>
-            <p:ph type="dt" sz="half" idx="10"/>
-          </p:nvPr>
-        </p:nvSpPr>
-        <p:spPr/>
-        <p:txBody>
-          <a:bodyPr/>
-          <a:lstStyle/>
-          <a:p>
-            <a:r>
-              <a:rPr lang="en-US"/>
-              <a:t>INSY 7130</a:t>
-            </a:r>
-          </a:p>
-        </p:txBody>
-      </p:sp>
-      <p:sp>
-        <p:nvSpPr>
-          <p:cNvPr id="5" name="Footer Placeholder 4">
-            <a:extLst>
-              <a:ext uri="{FF2B5EF4-FFF2-40B4-BE49-F238E27FC236}">
-                <a16:creationId xmlns:a16="http://schemas.microsoft.com/office/drawing/2014/main" id="{0530BE2B-C9B1-897B-89D9-FBC60B3B2447}"/>
-              </a:ext>
-            </a:extLst>
-          </p:cNvPr>
-          <p:cNvSpPr>
-            <a:spLocks noGrp="1"/>
-          </p:cNvSpPr>
-          <p:nvPr>
-            <p:ph type="ftr" sz="quarter" idx="11"/>
-          </p:nvPr>
-        </p:nvSpPr>
-        <p:spPr/>
-        <p:txBody>
-          <a:bodyPr/>
-          <a:lstStyle/>
-          <a:p>
-            <a:r>
-              <a:rPr lang="en-US"/>
-              <a:t>Industrial &amp; Systems Engineering, Auburn University</a:t>
-            </a:r>
-          </a:p>
-        </p:txBody>
-      </p:sp>
-      <p:sp>
-        <p:nvSpPr>
-          <p:cNvPr id="6" name="Slide Number Placeholder 5">
-            <a:extLst>
-              <a:ext uri="{FF2B5EF4-FFF2-40B4-BE49-F238E27FC236}">
-                <a16:creationId xmlns:a16="http://schemas.microsoft.com/office/drawing/2014/main" id="{0CC372B0-7CB1-DB41-8BE3-E4B42C07993D}"/>
-              </a:ext>
-            </a:extLst>
-          </p:cNvPr>
-          <p:cNvSpPr>
-            <a:spLocks noGrp="1"/>
-          </p:cNvSpPr>
-          <p:nvPr>
-            <p:ph type="sldNum" sz="quarter" idx="12"/>
-          </p:nvPr>
-        </p:nvSpPr>
-        <p:spPr/>
-        <p:txBody>
-          <a:bodyPr/>
-          <a:lstStyle/>
-          <a:p>
-            <a:fld id="{865A0CD8-E904-E941-9989-44DD9BC4F0EA}" type="slidenum">
-              <a:rPr lang="en-US" smtClean="0"/>
-              <a:t>4</a:t>
-            </a:fld>
-            <a:endParaRPr lang="en-US"/>
+              <a:t>Use both selectively as references to return to, not as second courses to complete.</a:t>
+            </a:r>
           </a:p>
         </p:txBody>
       </p:sp>
@@ -4601,7 +4264,7 @@
 </file>
 
 <file path=ppt/slides/slide5.xml><?xml version="1.0" encoding="utf-8"?>
-<p:sld xmlns:a="http://schemas.openxmlformats.org/drawingml/2006/main" xmlns:r="http://schemas.openxmlformats.org/officeDocument/2006/relationships" xmlns:p="http://schemas.openxmlformats.org/presentationml/2006/main">
+<p:sld xmlns:a="http://schemas.openxmlformats.org/drawingml/2006/main" xmlns:p="http://schemas.openxmlformats.org/presentationml/2006/main" xmlns:r="http://schemas.openxmlformats.org/officeDocument/2006/relationships">
   <p:cSld>
     <p:spTree>
       <p:nvGrpSpPr>
@@ -4609,14 +4272,7 @@
         <p:cNvGrpSpPr/>
         <p:nvPr/>
       </p:nvGrpSpPr>
-      <p:grpSpPr>
-        <a:xfrm>
-          <a:off x="0" y="0"/>
-          <a:ext cx="0" cy="0"/>
-          <a:chOff x="0" y="0"/>
-          <a:chExt cx="0" cy="0"/>
-        </a:xfrm>
-      </p:grpSpPr>
+      <p:grpSpPr/>
       <p:sp>
         <p:nvSpPr>
           <p:cNvPr id="2" name="Title 1"/>
@@ -4650,124 +4306,42 @@
         </p:nvSpPr>
         <p:spPr/>
         <p:txBody>
-          <a:bodyPr>
-            <a:normAutofit lnSpcReduction="10000"/>
-          </a:bodyPr>
-          <a:lstStyle/>
-          <a:p>
+          <a:bodyPr/>
+          <a:lstStyle/>
+          <a:p>
+            <a:pPr/>
             <a:r>
               <a:rPr sz="2800"/>
               <a:t>Question and scope: What decision, population, or process is under study?</a:t>
             </a:r>
           </a:p>
           <a:p>
+            <a:pPr/>
             <a:r>
               <a:rPr sz="2800"/>
               <a:t>Data and provenance: What does a record represent, and where did the data come from?</a:t>
             </a:r>
           </a:p>
           <a:p>
+            <a:pPr/>
             <a:r>
               <a:rPr sz="2800"/>
               <a:t>Representation and statistic: Which variables and summary stand for the pattern of interest?</a:t>
             </a:r>
           </a:p>
           <a:p>
+            <a:pPr/>
             <a:r>
               <a:rPr sz="2800"/>
               <a:t>Comparison and evidence: Compared with what, and what result changed the conclusion?</a:t>
             </a:r>
           </a:p>
           <a:p>
+            <a:pPr/>
             <a:r>
               <a:rPr sz="2800"/>
               <a:t>Limit and next check: What does the result not establish, and what should happen next?</a:t>
             </a:r>
-          </a:p>
-        </p:txBody>
-      </p:sp>
-      <p:sp>
-        <p:nvSpPr>
-          <p:cNvPr id="4" name="Date Placeholder 3">
-            <a:extLst>
-              <a:ext uri="{FF2B5EF4-FFF2-40B4-BE49-F238E27FC236}">
-                <a16:creationId xmlns:a16="http://schemas.microsoft.com/office/drawing/2014/main" id="{BB83DB3B-3744-558B-5236-58D13768BBA7}"/>
-              </a:ext>
-            </a:extLst>
-          </p:cNvPr>
-          <p:cNvSpPr>
-            <a:spLocks noGrp="1"/>
-          </p:cNvSpPr>
-          <p:nvPr>
-            <p:ph type="dt" sz="half" idx="10"/>
-          </p:nvPr>
-        </p:nvSpPr>
-        <p:spPr/>
-        <p:txBody>
-          <a:bodyPr/>
-          <a:lstStyle/>
-          <a:p>
-            <a:r>
-              <a:rPr lang="en-US"/>
-              <a:t>INSY 7130</a:t>
-            </a:r>
-          </a:p>
-        </p:txBody>
-      </p:sp>
-      <p:sp>
-        <p:nvSpPr>
-          <p:cNvPr id="5" name="Footer Placeholder 4">
-            <a:extLst>
-              <a:ext uri="{FF2B5EF4-FFF2-40B4-BE49-F238E27FC236}">
-                <a16:creationId xmlns:a16="http://schemas.microsoft.com/office/drawing/2014/main" id="{90481CD5-076F-D4AD-3CB9-3C808EB5C142}"/>
-              </a:ext>
-            </a:extLst>
-          </p:cNvPr>
-          <p:cNvSpPr>
-            <a:spLocks noGrp="1"/>
-          </p:cNvSpPr>
-          <p:nvPr>
-            <p:ph type="ftr" sz="quarter" idx="11"/>
-          </p:nvPr>
-        </p:nvSpPr>
-        <p:spPr/>
-        <p:txBody>
-          <a:bodyPr/>
-          <a:lstStyle/>
-          <a:p>
-            <a:r>
-              <a:rPr lang="en-US"/>
-              <a:t>Industrial &amp; Systems Engineering, Auburn University</a:t>
-            </a:r>
-          </a:p>
-        </p:txBody>
-      </p:sp>
-      <p:sp>
-        <p:nvSpPr>
-          <p:cNvPr id="6" name="Slide Number Placeholder 5">
-            <a:extLst>
-              <a:ext uri="{FF2B5EF4-FFF2-40B4-BE49-F238E27FC236}">
-                <a16:creationId xmlns:a16="http://schemas.microsoft.com/office/drawing/2014/main" id="{AF8C4ED4-CA29-BEE8-D1B1-68FEB7CBF581}"/>
-              </a:ext>
-            </a:extLst>
-          </p:cNvPr>
-          <p:cNvSpPr>
-            <a:spLocks noGrp="1"/>
-          </p:cNvSpPr>
-          <p:nvPr>
-            <p:ph type="sldNum" sz="quarter" idx="12"/>
-          </p:nvPr>
-        </p:nvSpPr>
-        <p:spPr/>
-        <p:txBody>
-          <a:bodyPr/>
-          <a:lstStyle/>
-          <a:p>
-            <a:fld id="{865A0CD8-E904-E941-9989-44DD9BC4F0EA}" type="slidenum">
-              <a:rPr lang="en-US" smtClean="0"/>
-              <a:t>5</a:t>
-            </a:fld>
-            <a:endParaRPr lang="en-US"/>
           </a:p>
         </p:txBody>
       </p:sp>
@@ -4780,7 +4354,7 @@
 </file>
 
 <file path=ppt/slides/slide6.xml><?xml version="1.0" encoding="utf-8"?>
-<p:sld xmlns:a="http://schemas.openxmlformats.org/drawingml/2006/main" xmlns:r="http://schemas.openxmlformats.org/officeDocument/2006/relationships" xmlns:p="http://schemas.openxmlformats.org/presentationml/2006/main">
+<p:sld xmlns:a="http://schemas.openxmlformats.org/drawingml/2006/main" xmlns:p="http://schemas.openxmlformats.org/presentationml/2006/main" xmlns:r="http://schemas.openxmlformats.org/officeDocument/2006/relationships">
   <p:cSld>
     <p:spTree>
       <p:nvGrpSpPr>
@@ -4788,14 +4362,7 @@
         <p:cNvGrpSpPr/>
         <p:nvPr/>
       </p:nvGrpSpPr>
-      <p:grpSpPr>
-        <a:xfrm>
-          <a:off x="0" y="0"/>
-          <a:ext cx="0" cy="0"/>
-          <a:chOff x="0" y="0"/>
-          <a:chExt cx="0" cy="0"/>
-        </a:xfrm>
-      </p:grpSpPr>
+      <p:grpSpPr/>
       <p:sp>
         <p:nvSpPr>
           <p:cNvPr id="2" name="Title 1"/>
@@ -4832,24 +4399,28 @@
           <a:bodyPr/>
           <a:lstStyle/>
           <a:p>
+            <a:pPr/>
             <a:r>
               <a:rPr sz="2800"/>
               <a:t>pandas works with tables, selections, and group summaries.</a:t>
             </a:r>
           </a:p>
           <a:p>
+            <a:pPr/>
             <a:r>
               <a:rPr sz="2800"/>
               <a:t>NumPy supplies arrays, numerical computation, and reproducible random-number generation.</a:t>
             </a:r>
           </a:p>
           <a:p>
+            <a:pPr/>
             <a:r>
               <a:rPr sz="2800"/>
               <a:t>Matplotlib makes visual evidence that can be inspected and discussed.</a:t>
             </a:r>
           </a:p>
           <a:p>
+            <a:pPr/>
             <a:r>
               <a:rPr sz="2800"/>
               <a:t>SciPy provides scientific-computing methods; </a:t>
@@ -4867,91 +4438,6 @@
               <a:rPr sz="2800"/>
               <a:t> includes statistical tests and resampling tools.</a:t>
             </a:r>
-          </a:p>
-        </p:txBody>
-      </p:sp>
-      <p:sp>
-        <p:nvSpPr>
-          <p:cNvPr id="4" name="Date Placeholder 3">
-            <a:extLst>
-              <a:ext uri="{FF2B5EF4-FFF2-40B4-BE49-F238E27FC236}">
-                <a16:creationId xmlns:a16="http://schemas.microsoft.com/office/drawing/2014/main" id="{5979F506-B515-67CE-4686-18E1A3310A1C}"/>
-              </a:ext>
-            </a:extLst>
-          </p:cNvPr>
-          <p:cNvSpPr>
-            <a:spLocks noGrp="1"/>
-          </p:cNvSpPr>
-          <p:nvPr>
-            <p:ph type="dt" sz="half" idx="10"/>
-          </p:nvPr>
-        </p:nvSpPr>
-        <p:spPr/>
-        <p:txBody>
-          <a:bodyPr/>
-          <a:lstStyle/>
-          <a:p>
-            <a:r>
-              <a:rPr lang="en-US"/>
-              <a:t>INSY 7130</a:t>
-            </a:r>
-          </a:p>
-        </p:txBody>
-      </p:sp>
-      <p:sp>
-        <p:nvSpPr>
-          <p:cNvPr id="5" name="Footer Placeholder 4">
-            <a:extLst>
-              <a:ext uri="{FF2B5EF4-FFF2-40B4-BE49-F238E27FC236}">
-                <a16:creationId xmlns:a16="http://schemas.microsoft.com/office/drawing/2014/main" id="{3444B648-7297-CDA4-8EAC-880AB51B8489}"/>
-              </a:ext>
-            </a:extLst>
-          </p:cNvPr>
-          <p:cNvSpPr>
-            <a:spLocks noGrp="1"/>
-          </p:cNvSpPr>
-          <p:nvPr>
-            <p:ph type="ftr" sz="quarter" idx="11"/>
-          </p:nvPr>
-        </p:nvSpPr>
-        <p:spPr/>
-        <p:txBody>
-          <a:bodyPr/>
-          <a:lstStyle/>
-          <a:p>
-            <a:r>
-              <a:rPr lang="en-US"/>
-              <a:t>Industrial &amp; Systems Engineering, Auburn University</a:t>
-            </a:r>
-          </a:p>
-        </p:txBody>
-      </p:sp>
-      <p:sp>
-        <p:nvSpPr>
-          <p:cNvPr id="6" name="Slide Number Placeholder 5">
-            <a:extLst>
-              <a:ext uri="{FF2B5EF4-FFF2-40B4-BE49-F238E27FC236}">
-                <a16:creationId xmlns:a16="http://schemas.microsoft.com/office/drawing/2014/main" id="{B889E6F6-4C12-3589-6712-8F9A7067F0C7}"/>
-              </a:ext>
-            </a:extLst>
-          </p:cNvPr>
-          <p:cNvSpPr>
-            <a:spLocks noGrp="1"/>
-          </p:cNvSpPr>
-          <p:nvPr>
-            <p:ph type="sldNum" sz="quarter" idx="12"/>
-          </p:nvPr>
-        </p:nvSpPr>
-        <p:spPr/>
-        <p:txBody>
-          <a:bodyPr/>
-          <a:lstStyle/>
-          <a:p>
-            <a:fld id="{865A0CD8-E904-E941-9989-44DD9BC4F0EA}" type="slidenum">
-              <a:rPr lang="en-US" smtClean="0"/>
-              <a:t>6</a:t>
-            </a:fld>
-            <a:endParaRPr lang="en-US"/>
           </a:p>
         </p:txBody>
       </p:sp>
@@ -4964,7 +4450,7 @@
 </file>
 
 <file path=ppt/slides/slide7.xml><?xml version="1.0" encoding="utf-8"?>
-<p:sld xmlns:a="http://schemas.openxmlformats.org/drawingml/2006/main" xmlns:r="http://schemas.openxmlformats.org/officeDocument/2006/relationships" xmlns:p="http://schemas.openxmlformats.org/presentationml/2006/main">
+<p:sld xmlns:a="http://schemas.openxmlformats.org/drawingml/2006/main" xmlns:p="http://schemas.openxmlformats.org/presentationml/2006/main" xmlns:r="http://schemas.openxmlformats.org/officeDocument/2006/relationships">
   <p:cSld>
     <p:spTree>
       <p:nvGrpSpPr>
@@ -4972,14 +4458,7 @@
         <p:cNvGrpSpPr/>
         <p:nvPr/>
       </p:nvGrpSpPr>
-      <p:grpSpPr>
-        <a:xfrm>
-          <a:off x="0" y="0"/>
-          <a:ext cx="0" cy="0"/>
-          <a:chOff x="0" y="0"/>
-          <a:chExt cx="0" cy="0"/>
-        </a:xfrm>
-      </p:grpSpPr>
+      <p:grpSpPr/>
       <p:sp>
         <p:nvSpPr>
           <p:cNvPr id="2" name="Title 1"/>
@@ -5016,18 +4495,21 @@
           <a:bodyPr/>
           <a:lstStyle/>
           <a:p>
+            <a:pPr/>
             <a:r>
               <a:rPr sz="2800"/>
               <a:t>Unit 1 begins with a simple comparison and two kinds of resampling evidence.</a:t>
             </a:r>
           </a:p>
           <a:p>
+            <a:pPr/>
             <a:r>
               <a:rPr sz="2800"/>
               <a:t>Later units use the same discipline for distances, embeddings, clusters, rules, anomalies, and forecasts.</a:t>
             </a:r>
           </a:p>
           <a:p>
+            <a:pPr/>
             <a:r>
               <a:rPr sz="2800"/>
               <a:t>The method changes; the questions persist:</a:t>
@@ -5055,95 +4537,11 @@
             </a:r>
           </a:p>
           <a:p>
+            <a:pPr/>
             <a:r>
               <a:rPr sz="2800"/>
               <a:t>Start with the record. Let the evidence determine the claim.</a:t>
             </a:r>
-          </a:p>
-        </p:txBody>
-      </p:sp>
-      <p:sp>
-        <p:nvSpPr>
-          <p:cNvPr id="4" name="Date Placeholder 3">
-            <a:extLst>
-              <a:ext uri="{FF2B5EF4-FFF2-40B4-BE49-F238E27FC236}">
-                <a16:creationId xmlns:a16="http://schemas.microsoft.com/office/drawing/2014/main" id="{7EF7E317-098C-BCA7-84D3-01FD03548BE8}"/>
-              </a:ext>
-            </a:extLst>
-          </p:cNvPr>
-          <p:cNvSpPr>
-            <a:spLocks noGrp="1"/>
-          </p:cNvSpPr>
-          <p:nvPr>
-            <p:ph type="dt" sz="half" idx="10"/>
-          </p:nvPr>
-        </p:nvSpPr>
-        <p:spPr/>
-        <p:txBody>
-          <a:bodyPr/>
-          <a:lstStyle/>
-          <a:p>
-            <a:r>
-              <a:rPr lang="en-US"/>
-              <a:t>INSY 7130</a:t>
-            </a:r>
-          </a:p>
-        </p:txBody>
-      </p:sp>
-      <p:sp>
-        <p:nvSpPr>
-          <p:cNvPr id="5" name="Footer Placeholder 4">
-            <a:extLst>
-              <a:ext uri="{FF2B5EF4-FFF2-40B4-BE49-F238E27FC236}">
-                <a16:creationId xmlns:a16="http://schemas.microsoft.com/office/drawing/2014/main" id="{9AB8D4ED-8D5C-430A-7A3E-052B6C3AAD30}"/>
-              </a:ext>
-            </a:extLst>
-          </p:cNvPr>
-          <p:cNvSpPr>
-            <a:spLocks noGrp="1"/>
-          </p:cNvSpPr>
-          <p:nvPr>
-            <p:ph type="ftr" sz="quarter" idx="11"/>
-          </p:nvPr>
-        </p:nvSpPr>
-        <p:spPr/>
-        <p:txBody>
-          <a:bodyPr/>
-          <a:lstStyle/>
-          <a:p>
-            <a:r>
-              <a:rPr lang="en-US"/>
-              <a:t>Industrial &amp; Systems Engineering, Auburn University</a:t>
-            </a:r>
-          </a:p>
-        </p:txBody>
-      </p:sp>
-      <p:sp>
-        <p:nvSpPr>
-          <p:cNvPr id="6" name="Slide Number Placeholder 5">
-            <a:extLst>
-              <a:ext uri="{FF2B5EF4-FFF2-40B4-BE49-F238E27FC236}">
-                <a16:creationId xmlns:a16="http://schemas.microsoft.com/office/drawing/2014/main" id="{D3B79319-3BCB-E09A-9E6E-42E2C5C57E08}"/>
-              </a:ext>
-            </a:extLst>
-          </p:cNvPr>
-          <p:cNvSpPr>
-            <a:spLocks noGrp="1"/>
-          </p:cNvSpPr>
-          <p:nvPr>
-            <p:ph type="sldNum" sz="quarter" idx="12"/>
-          </p:nvPr>
-        </p:nvSpPr>
-        <p:spPr/>
-        <p:txBody>
-          <a:bodyPr/>
-          <a:lstStyle/>
-          <a:p>
-            <a:fld id="{865A0CD8-E904-E941-9989-44DD9BC4F0EA}" type="slidenum">
-              <a:rPr lang="en-US" smtClean="0"/>
-              <a:t>7</a:t>
-            </a:fld>
-            <a:endParaRPr lang="en-US"/>
           </a:p>
         </p:txBody>
       </p:sp>

</xml_diff>